<commit_message>
Enhance architecture diagram and update presentation materials for Student Performance Prediction Agent. Improved the diagram's design to include all components and feedback loops, and updated the PowerPoint presentation with new visuals and layout adjustments. Increased diagram resolution and adjusted presentation dimensions for better clarity.
</commit_message>
<xml_diff>
--- a/ppt/Student_Performance_Prediction_Agent.pptx
+++ b/ppt/Student_Performance_Prediction_Agent.pptx
@@ -8890,8 +8890,8 @@
         </p:blipFill>
         <p:spPr>
           <a:xfrm>
-            <a:off x="320040" y="3200400"/>
-            <a:ext cx="8229600" cy="1463040"/>
+            <a:off x="228600" y="3063240"/>
+            <a:ext cx="8503920" cy="1920240"/>
           </a:xfrm>
           <a:prstGeom prst="rect">
             <a:avLst/>

</xml_diff>